<commit_message>
pipeline graph generation ready
</commit_message>
<xml_diff>
--- a/tests/.tmp/filmstrip_p2g_pipeline/d76fbd4b_20251215_142352/filmstrip_output.pptx
+++ b/tests/.tmp/filmstrip_p2g_pipeline/d76fbd4b_20251215_142352/filmstrip_output.pptx
@@ -3099,13 +3099,14 @@
             <a:off x="2028825" y="2452687"/>
             <a:ext cx="600075" cy="0"/>
           </a:xfrm>
-          <a:prstGeom prst="line">
+          <a:prstGeom prst="bentConnector3">
             <a:avLst/>
           </a:prstGeom>
-          <a:ln w="19050">
+          <a:ln w="25400">
             <a:solidFill>
-              <a:srgbClr val="808080"/>
+              <a:srgbClr val="555555"/>
             </a:solidFill>
+            <a:tailEnd type="triangle" w="med" len="med"/>
           </a:ln>
         </p:spPr>
         <p:style>
@@ -3134,13 +3135,14 @@
             <a:off x="4219575" y="2443162"/>
             <a:ext cx="723900" cy="9525"/>
           </a:xfrm>
-          <a:prstGeom prst="line">
+          <a:prstGeom prst="bentConnector3">
             <a:avLst/>
           </a:prstGeom>
-          <a:ln w="19050">
+          <a:ln w="25400">
             <a:solidFill>
-              <a:srgbClr val="808080"/>
+              <a:srgbClr val="555555"/>
             </a:solidFill>
+            <a:tailEnd type="triangle" w="med" len="med"/>
           </a:ln>
         </p:spPr>
         <p:style>
@@ -3169,13 +3171,14 @@
             <a:off x="6543675" y="1928812"/>
             <a:ext cx="733425" cy="514350"/>
           </a:xfrm>
-          <a:prstGeom prst="line">
+          <a:prstGeom prst="bentConnector3">
             <a:avLst/>
           </a:prstGeom>
-          <a:ln w="19050">
+          <a:ln w="25400">
             <a:solidFill>
-              <a:srgbClr val="808080"/>
+              <a:srgbClr val="555555"/>
             </a:solidFill>
+            <a:tailEnd type="triangle" w="med" len="med"/>
           </a:ln>
         </p:spPr>
         <p:style>
@@ -3201,16 +3204,17 @@
         </p:nvCxnSpPr>
         <p:spPr>
           <a:xfrm>
-            <a:off x="2028825" y="2452687"/>
-            <a:ext cx="628650" cy="752475"/>
-          </a:xfrm>
-          <a:prstGeom prst="line">
+            <a:off x="1300162" y="2847975"/>
+            <a:ext cx="2119313" cy="95250"/>
+          </a:xfrm>
+          <a:prstGeom prst="bentConnector3">
             <a:avLst/>
           </a:prstGeom>
-          <a:ln w="19050">
+          <a:ln w="25400">
             <a:solidFill>
-              <a:srgbClr val="808080"/>
+              <a:srgbClr val="555555"/>
             </a:solidFill>
+            <a:tailEnd type="triangle" w="med" len="med"/>
           </a:ln>
         </p:spPr>
         <p:style>
@@ -3239,13 +3243,14 @@
             <a:off x="4181475" y="3205162"/>
             <a:ext cx="638175" cy="514350"/>
           </a:xfrm>
-          <a:prstGeom prst="line">
+          <a:prstGeom prst="bentConnector3">
             <a:avLst/>
           </a:prstGeom>
-          <a:ln w="19050">
+          <a:ln w="25400">
             <a:solidFill>
-              <a:srgbClr val="808080"/>
+              <a:srgbClr val="555555"/>
             </a:solidFill>
+            <a:tailEnd type="triangle" w="med" len="med"/>
           </a:ln>
         </p:spPr>
         <p:style>
@@ -3274,13 +3279,14 @@
             <a:off x="9001125" y="985837"/>
             <a:ext cx="638175" cy="942975"/>
           </a:xfrm>
-          <a:prstGeom prst="line">
+          <a:prstGeom prst="bentConnector3">
             <a:avLst/>
           </a:prstGeom>
-          <a:ln w="19050">
+          <a:ln w="25400">
             <a:solidFill>
-              <a:srgbClr val="808080"/>
+              <a:srgbClr val="555555"/>
             </a:solidFill>
+            <a:tailEnd type="triangle" w="med" len="med"/>
           </a:ln>
         </p:spPr>
         <p:style>
@@ -3309,13 +3315,14 @@
             <a:off x="11229975" y="985837"/>
             <a:ext cx="733425" cy="504825"/>
           </a:xfrm>
-          <a:prstGeom prst="line">
+          <a:prstGeom prst="bentConnector3">
             <a:avLst/>
           </a:prstGeom>
-          <a:ln w="19050">
+          <a:ln w="25400">
             <a:solidFill>
-              <a:srgbClr val="808080"/>
+              <a:srgbClr val="555555"/>
             </a:solidFill>
+            <a:tailEnd type="triangle" w="med" len="med"/>
           </a:ln>
         </p:spPr>
         <p:style>
@@ -3344,13 +3351,14 @@
             <a:off x="13687425" y="1490662"/>
             <a:ext cx="762000" cy="0"/>
           </a:xfrm>
-          <a:prstGeom prst="line">
+          <a:prstGeom prst="bentConnector3">
             <a:avLst/>
           </a:prstGeom>
-          <a:ln w="19050">
+          <a:ln w="25400">
             <a:solidFill>
-              <a:srgbClr val="808080"/>
+              <a:srgbClr val="555555"/>
             </a:solidFill>
+            <a:tailEnd type="triangle" w="med" len="med"/>
           </a:ln>
         </p:spPr>
         <p:style>
@@ -3379,13 +3387,14 @@
             <a:off x="16049625" y="1490662"/>
             <a:ext cx="666750" cy="4763"/>
           </a:xfrm>
-          <a:prstGeom prst="line">
+          <a:prstGeom prst="bentConnector3">
             <a:avLst/>
           </a:prstGeom>
-          <a:ln w="19050">
+          <a:ln w="25400">
             <a:solidFill>
-              <a:srgbClr val="808080"/>
+              <a:srgbClr val="555555"/>
             </a:solidFill>
+            <a:tailEnd type="triangle" w="med" len="med"/>
           </a:ln>
         </p:spPr>
         <p:style>
@@ -3414,13 +3423,14 @@
             <a:off x="6677025" y="3205162"/>
             <a:ext cx="657225" cy="514350"/>
           </a:xfrm>
-          <a:prstGeom prst="line">
+          <a:prstGeom prst="bentConnector3">
             <a:avLst/>
           </a:prstGeom>
-          <a:ln w="19050">
+          <a:ln w="25400">
             <a:solidFill>
-              <a:srgbClr val="808080"/>
+              <a:srgbClr val="555555"/>
             </a:solidFill>
+            <a:tailEnd type="triangle" w="med" len="med"/>
           </a:ln>
         </p:spPr>
         <p:style>
@@ -3449,13 +3459,14 @@
             <a:off x="8934450" y="2014537"/>
             <a:ext cx="666750" cy="1190625"/>
           </a:xfrm>
-          <a:prstGeom prst="line">
+          <a:prstGeom prst="bentConnector3">
             <a:avLst/>
           </a:prstGeom>
-          <a:ln w="19050">
+          <a:ln w="25400">
             <a:solidFill>
-              <a:srgbClr val="808080"/>
+              <a:srgbClr val="555555"/>
             </a:solidFill>
+            <a:tailEnd type="triangle" w="med" len="med"/>
           </a:ln>
         </p:spPr>
         <p:style>
@@ -3480,17 +3491,18 @@
           <p:nvPr/>
         </p:nvCxnSpPr>
         <p:spPr>
-          <a:xfrm>
-            <a:off x="2028825" y="2452687"/>
-            <a:ext cx="9839325" cy="366713"/>
-          </a:xfrm>
-          <a:prstGeom prst="line">
+          <a:xfrm flipV="1">
+            <a:off x="1300162" y="2524125"/>
+            <a:ext cx="11530013" cy="323850"/>
+          </a:xfrm>
+          <a:prstGeom prst="bentConnector3">
             <a:avLst/>
           </a:prstGeom>
-          <a:ln w="19050">
+          <a:ln w="25400">
             <a:solidFill>
-              <a:srgbClr val="808080"/>
+              <a:srgbClr val="555555"/>
             </a:solidFill>
+            <a:tailEnd type="triangle" w="med" len="med"/>
           </a:ln>
         </p:spPr>
         <p:style>
@@ -3519,13 +3531,14 @@
             <a:off x="11258550" y="2014537"/>
             <a:ext cx="609600" cy="804863"/>
           </a:xfrm>
-          <a:prstGeom prst="line">
+          <a:prstGeom prst="bentConnector3">
             <a:avLst/>
           </a:prstGeom>
-          <a:ln w="19050">
+          <a:ln w="25400">
             <a:solidFill>
-              <a:srgbClr val="808080"/>
+              <a:srgbClr val="555555"/>
             </a:solidFill>
+            <a:tailEnd type="triangle" w="med" len="med"/>
           </a:ln>
         </p:spPr>
         <p:style>
@@ -3554,13 +3567,14 @@
             <a:off x="13792200" y="2819400"/>
             <a:ext cx="600075" cy="1328737"/>
           </a:xfrm>
-          <a:prstGeom prst="line">
+          <a:prstGeom prst="bentConnector3">
             <a:avLst/>
           </a:prstGeom>
-          <a:ln w="19050">
+          <a:ln w="25400">
             <a:solidFill>
-              <a:srgbClr val="808080"/>
+              <a:srgbClr val="555555"/>
             </a:solidFill>
+            <a:tailEnd type="triangle" w="med" len="med"/>
           </a:ln>
         </p:spPr>
         <p:style>

</xml_diff>